<commit_message>
Add bonus analysis (temporal features, subset comparison, PCA/UMAP) to code, report and slides
Co-Authored-By: Claude Sonnet 5.5 <noreply@anthropic.com>
</commit_message>
<xml_diff>
--- a/report/slides.pptx
+++ b/report/slides.pptx
@@ -12,6 +12,7 @@
     <p:sldId id="260" r:id="rId11"/>
     <p:sldId id="261" r:id="rId12"/>
     <p:sldId id="262" r:id="rId13"/>
+    <p:sldId id="263" r:id="rId14"/>
   </p:sldIdLst>
   <p:sldSz cx="12188952" cy="6858000" type="screen4x3"/>
   <p:notesSz cx="6858000" cy="9144000"/>
@@ -3697,6 +3698,124 @@
 </file>
 
 <file path=ppt/slides/slide7.xml><?xml version="1.0" encoding="utf-8"?>
+<p:sld xmlns:a="http://schemas.openxmlformats.org/drawingml/2006/main" xmlns:p="http://schemas.openxmlformats.org/presentationml/2006/main" xmlns:r="http://schemas.openxmlformats.org/officeDocument/2006/relationships">
+  <p:cSld>
+    <p:spTree>
+      <p:nvGrpSpPr>
+        <p:cNvPr id="1" name=""/>
+        <p:cNvGrpSpPr/>
+        <p:nvPr/>
+      </p:nvGrpSpPr>
+      <p:grpSpPr/>
+      <p:sp>
+        <p:nvSpPr>
+          <p:cNvPr id="2" name="Title 1"/>
+          <p:cNvSpPr>
+            <a:spLocks noGrp="1"/>
+          </p:cNvSpPr>
+          <p:nvPr>
+            <p:ph type="title"/>
+          </p:nvPr>
+        </p:nvSpPr>
+        <p:spPr/>
+        <p:txBody>
+          <a:bodyPr/>
+          <a:lstStyle/>
+          <a:p>
+            <a:r>
+              <a:t>Bonus: xu hướng nghe theo thời gian</a:t>
+            </a:r>
+          </a:p>
+        </p:txBody>
+      </p:sp>
+      <p:sp>
+        <p:nvSpPr>
+          <p:cNvPr id="3" name="TextBox 2"/>
+          <p:cNvSpPr txBox="1"/>
+          <p:nvPr/>
+        </p:nvSpPr>
+        <p:spPr>
+          <a:xfrm>
+            <a:off x="548640" y="1371600"/>
+            <a:ext cx="5760720" cy="5029200"/>
+          </a:xfrm>
+          <a:prstGeom prst="rect">
+            <a:avLst/>
+          </a:prstGeom>
+          <a:noFill/>
+        </p:spPr>
+        <p:txBody>
+          <a:bodyPr wrap="square">
+            <a:spAutoFit/>
+          </a:bodyPr>
+          <a:lstStyle/>
+          <a:p>
+            <a:pPr>
+              <a:defRPr sz="1800"/>
+            </a:pPr>
+            <a:r>
+              <a:t>• Nghe giảm mạnh: churn 77% (so với 34% khi tăng mạnh)</a:t>
+            </a:r>
+          </a:p>
+          <a:p>
+            <a:pPr>
+              <a:defRPr sz="1800"/>
+            </a:pPr>
+            <a:r>
+              <a:t>• Im lặng từ 15 ngày: churn 82%</a:t>
+            </a:r>
+          </a:p>
+          <a:p>
+            <a:pPr>
+              <a:defRPr sz="1800"/>
+            </a:pPr>
+            <a:r>
+              <a:t>• Thêm 2 biến thời gian: AUC (chỉ hành vi) 0,680 → 0,743</a:t>
+            </a:r>
+          </a:p>
+          <a:p>
+            <a:pPr>
+              <a:defRPr sz="1800"/>
+            </a:pPr>
+            <a:r>
+              <a:t>• Kênh 7 và người mới: hành vi dự báo tốt hơn; người lâu năm kém hơn</a:t>
+            </a:r>
+          </a:p>
+        </p:txBody>
+      </p:sp>
+      <p:pic>
+        <p:nvPicPr>
+          <p:cNvPr id="4" name="Picture 3" descr="umap_churn.png"/>
+          <p:cNvPicPr>
+            <a:picLocks noChangeAspect="1"/>
+          </p:cNvPicPr>
+          <p:nvPr/>
+        </p:nvPicPr>
+        <p:blipFill>
+          <a:blip r:embed="rId2"/>
+          <a:stretch>
+            <a:fillRect/>
+          </a:stretch>
+        </p:blipFill>
+        <p:spPr>
+          <a:xfrm>
+            <a:off x="6583680" y="1463040"/>
+            <a:ext cx="5120640" cy="4389120"/>
+          </a:xfrm>
+          <a:prstGeom prst="rect">
+            <a:avLst/>
+          </a:prstGeom>
+        </p:spPr>
+      </p:pic>
+    </p:spTree>
+  </p:cSld>
+  <p:clrMapOvr>
+    <a:masterClrMapping/>
+  </p:clrMapOvr>
+</p:sld>
+</file>
+
+<file path=ppt/slides/slide8.xml><?xml version="1.0" encoding="utf-8"?>
 <p:sld xmlns:a="http://schemas.openxmlformats.org/drawingml/2006/main" xmlns:p="http://schemas.openxmlformats.org/presentationml/2006/main" xmlns:r="http://schemas.openxmlformats.org/officeDocument/2006/relationships">
   <p:cSld>
     <p:spTree>

</xml_diff>